<commit_message>
Refresh chalumeau presentation exports
</commit_message>
<xml_diff>
--- a/build/presentation/capstone-deck.pptx
+++ b/build/presentation/capstone-deck.pptx
@@ -487,43 +487,43 @@
           <a:p>
             <a:r>
               <a:rPr lang="en-US" sz="1900"/>
-              <a:t>- drawing-brief.md defines required views, dimensions, datums, sketch intent.</a:t>
-            </a:r>
-          </a:p>
-          <a:p>
-            <a:r>
-              <a:rPr lang="en-US" sz="1900"/>
-              <a:t>- cad/ holds models and design tables.</a:t>
-            </a:r>
-          </a:p>
-          <a:p>
-            <a:r>
-              <a:rPr lang="en-US" sz="1900"/>
-              <a:t>- cnc/ holds CAM, toolpaths, setup sheets, dry-run notes.</a:t>
-            </a:r>
-          </a:p>
-          <a:p>
-            <a:r>
-              <a:rPr lang="en-US" sz="1900"/>
-              <a:t>- drawings/ holds PDFs, SVGs, DXFs, drawing exports.</a:t>
-            </a:r>
-          </a:p>
-          <a:p>
-            <a:r>
-              <a:rPr lang="en-US" sz="1900"/>
-              <a:t>- ![drawing](drawings/chalumeau-family-sheet.svg)</a:t>
-            </a:r>
-          </a:p>
-          <a:p>
-            <a:r>
-              <a:rPr lang="en-US" sz="1900"/>
-              <a:t>- ![drawing](drawings/chalumeau-soprano-c4-dimensioned.svg)</a:t>
-            </a:r>
-          </a:p>
-          <a:p>
-            <a:r>
-              <a:rPr lang="en-US" sz="1900"/>
-              <a:t>- ![drawing](drawings/keywork-lever-detail.svg)</a:t>
+              <a:t>- ../packet/drawing-brief.md defines required views, dimensions, datums, sketch intent.</a:t>
+            </a:r>
+          </a:p>
+          <a:p>
+            <a:r>
+              <a:rPr lang="en-US" sz="1900"/>
+              <a:t>- ../cad/ holds models and design tables.</a:t>
+            </a:r>
+          </a:p>
+          <a:p>
+            <a:r>
+              <a:rPr lang="en-US" sz="1900"/>
+              <a:t>- ../cnc/ holds CAM, toolpaths, setup sheets, dry-run notes.</a:t>
+            </a:r>
+          </a:p>
+          <a:p>
+            <a:r>
+              <a:rPr lang="en-US" sz="1900"/>
+              <a:t>- ../drawings/ holds PDFs, SVGs, DXFs, drawing exports.</a:t>
+            </a:r>
+          </a:p>
+          <a:p>
+            <a:r>
+              <a:rPr lang="en-US" sz="1900"/>
+              <a:t>- ![drawing](../drawings/chalumeau-family-sheet.svg)</a:t>
+            </a:r>
+          </a:p>
+          <a:p>
+            <a:r>
+              <a:rPr lang="en-US" sz="1900"/>
+              <a:t>- ![drawing](../drawings/chalumeau-soprano-c4-dimensioned.svg)</a:t>
+            </a:r>
+          </a:p>
+          <a:p>
+            <a:r>
+              <a:rPr lang="en-US" sz="1900"/>
+              <a:t>- ![drawing](../drawings/keywork-lever-detail.svg)</a:t>
             </a:r>
           </a:p>
         </p:txBody>
@@ -667,25 +667,25 @@
           <a:p>
             <a:r>
               <a:rPr lang="en-US" sz="1900"/>
-              <a:t>- images/chalumeau1.jpg</a:t>
-            </a:r>
-          </a:p>
-          <a:p>
-            <a:r>
-              <a:rPr lang="en-US" sz="1900"/>
-              <a:t>- images/chalumeau5.jpg</a:t>
-            </a:r>
-          </a:p>
-          <a:p>
-            <a:r>
-              <a:rPr lang="en-US" sz="1900"/>
-              <a:t>- ![image](images/chalumeau1.jpg)</a:t>
-            </a:r>
-          </a:p>
-          <a:p>
-            <a:r>
-              <a:rPr lang="en-US" sz="1900"/>
-              <a:t>- ![image](images/chalumeau5.jpg)</a:t>
+              <a:t>- ../../assets/images/chalumeau1.jpg</a:t>
+            </a:r>
+          </a:p>
+          <a:p>
+            <a:r>
+              <a:rPr lang="en-US" sz="1900"/>
+              <a:t>- ../../assets/images/chalumeau5.jpg</a:t>
+            </a:r>
+          </a:p>
+          <a:p>
+            <a:r>
+              <a:rPr lang="en-US" sz="1900"/>
+              <a:t>- ![image](../../assets/images/chalumeau1.jpg)</a:t>
+            </a:r>
+          </a:p>
+          <a:p>
+            <a:r>
+              <a:rPr lang="en-US" sz="1900"/>
+              <a:t>- ![image](../../assets/images/chalumeau5.jpg)</a:t>
             </a:r>
           </a:p>
         </p:txBody>
@@ -1813,19 +1813,19 @@
           <a:p>
             <a:r>
               <a:rPr lang="en-US" sz="1900"/>
-              <a:t>- Start with design.md for intent and assumptions.</a:t>
-            </a:r>
-          </a:p>
-          <a:p>
-            <a:r>
-              <a:rPr lang="en-US" sz="1900"/>
-              <a:t>- Use bom.csv, sourcing.csv, and cut-list.csv before buying or cutting.</a:t>
-            </a:r>
-          </a:p>
-          <a:p>
-            <a:r>
-              <a:rPr lang="en-US" sz="1900"/>
-              <a:t>- Use drawing-brief.md and CAD/CNC folders before machining.</a:t>
+              <a:t>- Start with ../packet/design.md for intent and assumptions.</a:t>
+            </a:r>
+          </a:p>
+          <a:p>
+            <a:r>
+              <a:rPr lang="en-US" sz="1900"/>
+              <a:t>- Use ../packet/bom.csv, ../packet/sourcing.csv, and ../packet/cut-list.csv before buying or cutting.</a:t>
+            </a:r>
+          </a:p>
+          <a:p>
+            <a:r>
+              <a:rPr lang="en-US" sz="1900"/>
+              <a:t>- Use ../packet/drawing-brief.md and CAD/CNC folders before machining.</a:t>
             </a:r>
           </a:p>
           <a:p>
@@ -1975,43 +1975,43 @@
           <a:p>
             <a:r>
               <a:rPr lang="en-US" sz="1900"/>
-              <a:t>- design.md: Project intent, catalog metadata, assumptions, and validation plan.</a:t>
-            </a:r>
-          </a:p>
-          <a:p>
-            <a:r>
-              <a:rPr lang="en-US" sz="1900"/>
-              <a:t>- bom.csv: Starter bill of materials with part categories, quantities, drawing refs, and notes.</a:t>
-            </a:r>
-          </a:p>
-          <a:p>
-            <a:r>
-              <a:rPr lang="en-US" sz="1900"/>
-              <a:t>- sourcing.csv: Supplier/search tracker with specs, price/date fields, lead time, substitutes, and risks.</a:t>
-            </a:r>
-          </a:p>
-          <a:p>
-            <a:r>
-              <a:rPr lang="en-US" sz="1900"/>
-              <a:t>- cut-list.csv: Rough/final stock sizes, material, grain/orientation, operations, yield, and offcuts.</a:t>
-            </a:r>
-          </a:p>
-          <a:p>
-            <a:r>
-              <a:rPr lang="en-US" sz="1900"/>
-              <a:t>- drawing-brief.md: Manufacturing drawing and technical product sketch brief.</a:t>
-            </a:r>
-          </a:p>
-          <a:p>
-            <a:r>
-              <a:rPr lang="en-US" sz="1900"/>
-              <a:t>- assembly-manual.md: Shop-facing sequence, tools, fixtures, safety, tuning, finishing, and maintenance notes.</a:t>
-            </a:r>
-          </a:p>
-          <a:p>
-            <a:r>
-              <a:rPr lang="en-US" sz="1900"/>
-              <a:t>- validation.csv: Target/measured values, tolerance, environment, result, and tuning/build action log.</a:t>
+              <a:t>- ../packet/design.md: Project intent, catalog metadata, assumptions, and validation plan.</a:t>
+            </a:r>
+          </a:p>
+          <a:p>
+            <a:r>
+              <a:rPr lang="en-US" sz="1900"/>
+              <a:t>- ../packet/bom.csv: Starter bill of materials with part categories, quantities, drawing refs, and notes.</a:t>
+            </a:r>
+          </a:p>
+          <a:p>
+            <a:r>
+              <a:rPr lang="en-US" sz="1900"/>
+              <a:t>- ../packet/sourcing.csv: Supplier/search tracker with specs, price/date fields, lead time, substitutes, and risks.</a:t>
+            </a:r>
+          </a:p>
+          <a:p>
+            <a:r>
+              <a:rPr lang="en-US" sz="1900"/>
+              <a:t>- ../packet/cut-list.csv: Rough/final stock sizes, material, grain/orientation, operations, yield, and offcuts.</a:t>
+            </a:r>
+          </a:p>
+          <a:p>
+            <a:r>
+              <a:rPr lang="en-US" sz="1900"/>
+              <a:t>- ../packet/drawing-brief.md: Manufacturing drawing and technical product sketch brief.</a:t>
+            </a:r>
+          </a:p>
+          <a:p>
+            <a:r>
+              <a:rPr lang="en-US" sz="1900"/>
+              <a:t>- ../packet/assembly-manual.md: Shop-facing sequence, tools, fixtures, safety, tuning, finishing, and maintenance notes.</a:t>
+            </a:r>
+          </a:p>
+          <a:p>
+            <a:r>
+              <a:rPr lang="en-US" sz="1900"/>
+              <a:t>- ../packet/validation.csv: Target/measured values, tolerance, environment, result, and tuning/build action log.</a:t>
             </a:r>
           </a:p>
         </p:txBody>

</xml_diff>

<commit_message>
Add chalumeau validation capture loop (#2)
* Add chalumeau validation capture loop

* Refresh chalumeau presentation exports

---------

Co-authored-by: AI Bot <bot@example.com>
</commit_message>
<xml_diff>
--- a/build/presentation/capstone-deck.pptx
+++ b/build/presentation/capstone-deck.pptx
@@ -487,43 +487,43 @@
           <a:p>
             <a:r>
               <a:rPr lang="en-US" sz="1900"/>
-              <a:t>- drawing-brief.md defines required views, dimensions, datums, sketch intent.</a:t>
-            </a:r>
-          </a:p>
-          <a:p>
-            <a:r>
-              <a:rPr lang="en-US" sz="1900"/>
-              <a:t>- cad/ holds models and design tables.</a:t>
-            </a:r>
-          </a:p>
-          <a:p>
-            <a:r>
-              <a:rPr lang="en-US" sz="1900"/>
-              <a:t>- cnc/ holds CAM, toolpaths, setup sheets, dry-run notes.</a:t>
-            </a:r>
-          </a:p>
-          <a:p>
-            <a:r>
-              <a:rPr lang="en-US" sz="1900"/>
-              <a:t>- drawings/ holds PDFs, SVGs, DXFs, drawing exports.</a:t>
-            </a:r>
-          </a:p>
-          <a:p>
-            <a:r>
-              <a:rPr lang="en-US" sz="1900"/>
-              <a:t>- ![drawing](drawings/chalumeau-family-sheet.svg)</a:t>
-            </a:r>
-          </a:p>
-          <a:p>
-            <a:r>
-              <a:rPr lang="en-US" sz="1900"/>
-              <a:t>- ![drawing](drawings/chalumeau-soprano-c4-dimensioned.svg)</a:t>
-            </a:r>
-          </a:p>
-          <a:p>
-            <a:r>
-              <a:rPr lang="en-US" sz="1900"/>
-              <a:t>- ![drawing](drawings/keywork-lever-detail.svg)</a:t>
+              <a:t>- ../packet/drawing-brief.md defines required views, dimensions, datums, sketch intent.</a:t>
+            </a:r>
+          </a:p>
+          <a:p>
+            <a:r>
+              <a:rPr lang="en-US" sz="1900"/>
+              <a:t>- ../cad/ holds models and design tables.</a:t>
+            </a:r>
+          </a:p>
+          <a:p>
+            <a:r>
+              <a:rPr lang="en-US" sz="1900"/>
+              <a:t>- ../cnc/ holds CAM, toolpaths, setup sheets, dry-run notes.</a:t>
+            </a:r>
+          </a:p>
+          <a:p>
+            <a:r>
+              <a:rPr lang="en-US" sz="1900"/>
+              <a:t>- ../drawings/ holds PDFs, SVGs, DXFs, drawing exports.</a:t>
+            </a:r>
+          </a:p>
+          <a:p>
+            <a:r>
+              <a:rPr lang="en-US" sz="1900"/>
+              <a:t>- ![drawing](../drawings/chalumeau-family-sheet.svg)</a:t>
+            </a:r>
+          </a:p>
+          <a:p>
+            <a:r>
+              <a:rPr lang="en-US" sz="1900"/>
+              <a:t>- ![drawing](../drawings/chalumeau-soprano-c4-dimensioned.svg)</a:t>
+            </a:r>
+          </a:p>
+          <a:p>
+            <a:r>
+              <a:rPr lang="en-US" sz="1900"/>
+              <a:t>- ![drawing](../drawings/keywork-lever-detail.svg)</a:t>
             </a:r>
           </a:p>
         </p:txBody>
@@ -667,25 +667,25 @@
           <a:p>
             <a:r>
               <a:rPr lang="en-US" sz="1900"/>
-              <a:t>- images/chalumeau1.jpg</a:t>
-            </a:r>
-          </a:p>
-          <a:p>
-            <a:r>
-              <a:rPr lang="en-US" sz="1900"/>
-              <a:t>- images/chalumeau5.jpg</a:t>
-            </a:r>
-          </a:p>
-          <a:p>
-            <a:r>
-              <a:rPr lang="en-US" sz="1900"/>
-              <a:t>- ![image](images/chalumeau1.jpg)</a:t>
-            </a:r>
-          </a:p>
-          <a:p>
-            <a:r>
-              <a:rPr lang="en-US" sz="1900"/>
-              <a:t>- ![image](images/chalumeau5.jpg)</a:t>
+              <a:t>- ../../assets/images/chalumeau1.jpg</a:t>
+            </a:r>
+          </a:p>
+          <a:p>
+            <a:r>
+              <a:rPr lang="en-US" sz="1900"/>
+              <a:t>- ../../assets/images/chalumeau5.jpg</a:t>
+            </a:r>
+          </a:p>
+          <a:p>
+            <a:r>
+              <a:rPr lang="en-US" sz="1900"/>
+              <a:t>- ![image](../../assets/images/chalumeau1.jpg)</a:t>
+            </a:r>
+          </a:p>
+          <a:p>
+            <a:r>
+              <a:rPr lang="en-US" sz="1900"/>
+              <a:t>- ![image](../../assets/images/chalumeau5.jpg)</a:t>
             </a:r>
           </a:p>
         </p:txBody>
@@ -1813,19 +1813,19 @@
           <a:p>
             <a:r>
               <a:rPr lang="en-US" sz="1900"/>
-              <a:t>- Start with design.md for intent and assumptions.</a:t>
-            </a:r>
-          </a:p>
-          <a:p>
-            <a:r>
-              <a:rPr lang="en-US" sz="1900"/>
-              <a:t>- Use bom.csv, sourcing.csv, and cut-list.csv before buying or cutting.</a:t>
-            </a:r>
-          </a:p>
-          <a:p>
-            <a:r>
-              <a:rPr lang="en-US" sz="1900"/>
-              <a:t>- Use drawing-brief.md and CAD/CNC folders before machining.</a:t>
+              <a:t>- Start with ../packet/design.md for intent and assumptions.</a:t>
+            </a:r>
+          </a:p>
+          <a:p>
+            <a:r>
+              <a:rPr lang="en-US" sz="1900"/>
+              <a:t>- Use ../packet/bom.csv, ../packet/sourcing.csv, and ../packet/cut-list.csv before buying or cutting.</a:t>
+            </a:r>
+          </a:p>
+          <a:p>
+            <a:r>
+              <a:rPr lang="en-US" sz="1900"/>
+              <a:t>- Use ../packet/drawing-brief.md and CAD/CNC folders before machining.</a:t>
             </a:r>
           </a:p>
           <a:p>
@@ -1975,43 +1975,43 @@
           <a:p>
             <a:r>
               <a:rPr lang="en-US" sz="1900"/>
-              <a:t>- design.md: Project intent, catalog metadata, assumptions, and validation plan.</a:t>
-            </a:r>
-          </a:p>
-          <a:p>
-            <a:r>
-              <a:rPr lang="en-US" sz="1900"/>
-              <a:t>- bom.csv: Starter bill of materials with part categories, quantities, drawing refs, and notes.</a:t>
-            </a:r>
-          </a:p>
-          <a:p>
-            <a:r>
-              <a:rPr lang="en-US" sz="1900"/>
-              <a:t>- sourcing.csv: Supplier/search tracker with specs, price/date fields, lead time, substitutes, and risks.</a:t>
-            </a:r>
-          </a:p>
-          <a:p>
-            <a:r>
-              <a:rPr lang="en-US" sz="1900"/>
-              <a:t>- cut-list.csv: Rough/final stock sizes, material, grain/orientation, operations, yield, and offcuts.</a:t>
-            </a:r>
-          </a:p>
-          <a:p>
-            <a:r>
-              <a:rPr lang="en-US" sz="1900"/>
-              <a:t>- drawing-brief.md: Manufacturing drawing and technical product sketch brief.</a:t>
-            </a:r>
-          </a:p>
-          <a:p>
-            <a:r>
-              <a:rPr lang="en-US" sz="1900"/>
-              <a:t>- assembly-manual.md: Shop-facing sequence, tools, fixtures, safety, tuning, finishing, and maintenance notes.</a:t>
-            </a:r>
-          </a:p>
-          <a:p>
-            <a:r>
-              <a:rPr lang="en-US" sz="1900"/>
-              <a:t>- validation.csv: Target/measured values, tolerance, environment, result, and tuning/build action log.</a:t>
+              <a:t>- ../packet/design.md: Project intent, catalog metadata, assumptions, and validation plan.</a:t>
+            </a:r>
+          </a:p>
+          <a:p>
+            <a:r>
+              <a:rPr lang="en-US" sz="1900"/>
+              <a:t>- ../packet/bom.csv: Starter bill of materials with part categories, quantities, drawing refs, and notes.</a:t>
+            </a:r>
+          </a:p>
+          <a:p>
+            <a:r>
+              <a:rPr lang="en-US" sz="1900"/>
+              <a:t>- ../packet/sourcing.csv: Supplier/search tracker with specs, price/date fields, lead time, substitutes, and risks.</a:t>
+            </a:r>
+          </a:p>
+          <a:p>
+            <a:r>
+              <a:rPr lang="en-US" sz="1900"/>
+              <a:t>- ../packet/cut-list.csv: Rough/final stock sizes, material, grain/orientation, operations, yield, and offcuts.</a:t>
+            </a:r>
+          </a:p>
+          <a:p>
+            <a:r>
+              <a:rPr lang="en-US" sz="1900"/>
+              <a:t>- ../packet/drawing-brief.md: Manufacturing drawing and technical product sketch brief.</a:t>
+            </a:r>
+          </a:p>
+          <a:p>
+            <a:r>
+              <a:rPr lang="en-US" sz="1900"/>
+              <a:t>- ../packet/assembly-manual.md: Shop-facing sequence, tools, fixtures, safety, tuning, finishing, and maintenance notes.</a:t>
+            </a:r>
+          </a:p>
+          <a:p>
+            <a:r>
+              <a:rPr lang="en-US" sz="1900"/>
+              <a:t>- ../packet/validation.csv: Target/measured values, tolerance, environment, result, and tuning/build action log.</a:t>
             </a:r>
           </a:p>
         </p:txBody>

</xml_diff>